<commit_message>
[pptx-compose-sv69] Regenerate localized fixtures
</commit_message>
<xml_diff>
--- a/fixtures/real-world/oecd-economic-outlook-2017-de.pptx
+++ b/fixtures/real-world/oecd-economic-outlook-2017-de.pptx
@@ -2767,19 +2767,19 @@
             <a:rPr lang="en-GB" dirty="0" smtClean="0">
               <a:latin typeface="Calibri" panose="020F0502020204030204" pitchFamily="34" charset="0"/>
             </a:rPr>
-            <a:t>Global growth expected to pick-up modestly </a:t>
+            <a:t>DE: Global growth expected to pick-up modestly </a:t>
           </a:r>
           <a:r>
             <a:rPr lang="en-GB" smtClean="0">
               <a:latin typeface="Calibri" panose="020F0502020204030204" pitchFamily="34" charset="0"/>
             </a:rPr>
-            <a:t>with upside </a:t>
+            <a:t>DE: with upside </a:t>
           </a:r>
           <a:r>
             <a:rPr lang="en-GB" dirty="0" smtClean="0">
               <a:latin typeface="Calibri" panose="020F0502020204030204" pitchFamily="34" charset="0"/>
             </a:rPr>
-            <a:t>risks</a:t>
+            <a:t>DE: risks</a:t>
           </a:r>
         </a:p>
       </dgm:t>
@@ -2821,7 +2821,7 @@
             <a:rPr lang="en-GB" dirty="0" smtClean="0">
               <a:latin typeface="Calibri" panose="020F0502020204030204" pitchFamily="34" charset="0"/>
             </a:rPr>
-            <a:t>More needs to be done to share the gains from structural trends and trade</a:t>
+            <a:t>DE: More needs to be done to share the gains from structural trends and trade</a:t>
           </a:r>
         </a:p>
       </dgm:t>
@@ -2863,7 +2863,7 @@
             <a:rPr lang="en-GB" dirty="0" smtClean="0">
               <a:latin typeface="Calibri" panose="020F0502020204030204" pitchFamily="34" charset="0"/>
             </a:rPr>
-            <a:t>An integrated policy approach is needed to make globalisation work for all</a:t>
+            <a:t>DE: An integrated policy approach is needed to make globalisation work for all</a:t>
           </a:r>
         </a:p>
       </dgm:t>
@@ -2910,7 +2910,7 @@
               </a:solidFill>
               <a:latin typeface="Calibri" panose="020F0502020204030204" pitchFamily="34" charset="0"/>
             </a:rPr>
-            <a:t>Changes to technology, consumer preferences and trade are occurring simultaneously</a:t>
+            <a:t>DE: Changes to technology, consumer preferences and trade are occurring simultaneously</a:t>
           </a:r>
         </a:p>
       </dgm:t>
@@ -2958,7 +2958,7 @@
               </a:solidFill>
               <a:latin typeface="Calibri" panose="020F0502020204030204" pitchFamily="34" charset="0"/>
             </a:rPr>
-            <a:t>A more level playing field for the international system</a:t>
+            <a:t>DE: A more level playing field for the international system</a:t>
           </a:r>
         </a:p>
       </dgm:t>
@@ -3005,7 +3005,7 @@
               </a:solidFill>
               <a:latin typeface="Calibri" panose="020F0502020204030204" pitchFamily="34" charset="0"/>
             </a:rPr>
-            <a:t>Confidence is increasing and investment and trade are picking up from low levels</a:t>
+            <a:t>DE: Confidence is increasing and investment and trade are picking up from low levels</a:t>
           </a:r>
         </a:p>
       </dgm:t>
@@ -3052,7 +3052,7 @@
               </a:solidFill>
               <a:latin typeface="Calibri" panose="020F0502020204030204" pitchFamily="34" charset="0"/>
             </a:rPr>
-            <a:t>Signs of rising demand for high-tech goods and investment to upgrade capital</a:t>
+            <a:t>DE: Signs of rising demand for high-tech goods and investment to upgrade capital</a:t>
           </a:r>
         </a:p>
       </dgm:t>
@@ -3100,7 +3100,7 @@
               </a:solidFill>
               <a:latin typeface="Calibri" panose="020F0502020204030204" pitchFamily="34" charset="0"/>
             </a:rPr>
-            <a:t>Domestic reforms to boost competition, job creation, skills and innovation</a:t>
+            <a:t>DE: Domestic reforms to boost competition, job creation, skills and innovation</a:t>
           </a:r>
         </a:p>
       </dgm:t>
@@ -3142,7 +3142,7 @@
             <a:rPr lang="en-GB" dirty="0" smtClean="0">
               <a:latin typeface="Calibri" panose="020F0502020204030204" pitchFamily="34" charset="0"/>
             </a:rPr>
-            <a:t>Productivity and wage growth remain subdued; financial stability risks persist</a:t>
+            <a:t>DE: Productivity and wage growth remain subdued; financial stability risks persist</a:t>
           </a:r>
         </a:p>
       </dgm:t>
@@ -3189,7 +3189,7 @@
               </a:solidFill>
               <a:latin typeface="Calibri" panose="020F0502020204030204" pitchFamily="34" charset="0"/>
             </a:rPr>
-            <a:t>Job losses from shifts in activity are concentrated in manufacturing and specific regions</a:t>
+            <a:t>DE: Job losses from shifts in activity are concentrated in manufacturing and specific regions</a:t>
           </a:r>
         </a:p>
       </dgm:t>
@@ -3236,7 +3236,7 @@
               </a:solidFill>
               <a:latin typeface="Calibri" panose="020F0502020204030204" pitchFamily="34" charset="0"/>
             </a:rPr>
-            <a:t>Growth is broad based; recovery in commodity producers helps the modest global upturn</a:t>
+            <a:t>DE: Growth is broad based; recovery in commodity producers helps the modest global upturn</a:t>
           </a:r>
           <a:endParaRPr lang="en-GB" dirty="0" smtClean="0">
             <a:solidFill>
@@ -3291,7 +3291,7 @@
               </a:solidFill>
               <a:latin typeface="Calibri" panose="020F0502020204030204" pitchFamily="34" charset="0"/>
             </a:rPr>
-            <a:t>Headline employment indicators are improving but labour markets have not recovered</a:t>
+            <a:t>DE: Headline employment indicators are improving but labour markets have not recovered</a:t>
           </a:r>
         </a:p>
       </dgm:t>
@@ -3338,7 +3338,7 @@
               </a:solidFill>
               <a:latin typeface="Calibri" panose="020F0502020204030204" pitchFamily="34" charset="0"/>
             </a:rPr>
-            <a:t>Financial risks from high and rising credit growth, house price increases, interest rate gaps</a:t>
+            <a:t>DE: Financial risks from high and rising credit growth, house price increases, interest rate gaps</a:t>
           </a:r>
           <a:endParaRPr lang="en-GB" dirty="0" smtClean="0">
             <a:solidFill>
@@ -3394,7 +3394,7 @@
               </a:solidFill>
               <a:latin typeface="Calibri" panose="020F0502020204030204" pitchFamily="34" charset="0"/>
             </a:rPr>
-            <a:t>Targeted policies to help people who are left behind seize new opportunities</a:t>
+            <a:t>DE: Targeted policies to help people who are left behind seize new opportunities</a:t>
           </a:r>
         </a:p>
       </dgm:t>
@@ -3636,7 +3636,7 @@
             <a:rPr lang="en-GB" sz="2000" dirty="0" smtClean="0">
               <a:latin typeface="Calibri" panose="020F0502020204030204" pitchFamily="34" charset="0"/>
             </a:rPr>
-            <a:t>Actions to improve the international environment:</a:t>
+            <a:t>DE: Actions to improve the international environment:</a:t>
           </a:r>
         </a:p>
       </dgm:t>
@@ -3683,7 +3683,7 @@
               </a:solidFill>
               <a:latin typeface="Calibri" panose="020F0502020204030204" pitchFamily="34" charset="0"/>
             </a:rPr>
-            <a:t>Preserve institutions and standards, such as for labour and environmental protection</a:t>
+            <a:t>DE: Preserve institutions and standards, such as for labour and environmental protection</a:t>
           </a:r>
         </a:p>
       </dgm:t>
@@ -3730,7 +3730,7 @@
               </a:solidFill>
               <a:latin typeface="Calibri" panose="020F0502020204030204" pitchFamily="34" charset="0"/>
             </a:rPr>
-            <a:t>Pursue open markets for cross-border trade and investment</a:t>
+            <a:t>DE: Pursue open markets for cross-border trade and investment</a:t>
           </a:r>
         </a:p>
       </dgm:t>
@@ -3777,7 +3777,7 @@
               </a:solidFill>
               <a:latin typeface="Calibri" panose="020F0502020204030204" pitchFamily="34" charset="0"/>
             </a:rPr>
-            <a:t>Promote multilateral cooperation, e.g. on tax base erosion and profit shifting and competition policy</a:t>
+            <a:t>DE: Promote multilateral cooperation, e.g. on tax base erosion and profit shifting and competition policy</a:t>
           </a:r>
         </a:p>
       </dgm:t>
@@ -3824,7 +3824,7 @@
               </a:solidFill>
               <a:latin typeface="Calibri" panose="020F0502020204030204" pitchFamily="34" charset="0"/>
             </a:rPr>
-            <a:t>Combat corruption, illicit trade and counterfeiting</a:t>
+            <a:t>DE: Combat corruption, illicit trade and counterfeiting</a:t>
           </a:r>
         </a:p>
       </dgm:t>
@@ -4079,7 +4079,7 @@
             <a:rPr lang="en-GB" sz="1600" b="1" dirty="0" smtClean="0">
               <a:latin typeface="Calibri" panose="020F0502020204030204" pitchFamily="34" charset="0"/>
             </a:rPr>
-            <a:t>Make the international system fairer and work better</a:t>
+            <a:t>DE: Make the international system fairer and work better</a:t>
           </a:r>
           <a:endParaRPr lang="en-GB" sz="1600" b="1" dirty="0">
             <a:latin typeface="Calibri" panose="020F0502020204030204" pitchFamily="34" charset="0"/>
@@ -4127,7 +4127,7 @@
               </a:solidFill>
               <a:latin typeface="Calibri" panose="020F0502020204030204" pitchFamily="34" charset="0"/>
             </a:rPr>
-            <a:t>Policies to encourage new firms, innovation &amp; job creation</a:t>
+            <a:t>DE: Policies to encourage new firms, innovation  job creation</a:t>
           </a:r>
           <a:endParaRPr lang="en-GB" sz="1600" b="1" dirty="0">
             <a:solidFill>
@@ -4175,13 +4175,13 @@
             <a:rPr lang="en-GB" sz="1600" b="1" dirty="0" smtClean="0">
               <a:latin typeface="Calibri" panose="020F0502020204030204" pitchFamily="34" charset="0"/>
             </a:rPr>
-            <a:t>Targeted policies to help people seize new </a:t>
+            <a:t>DE: Targeted policies to help people seize new </a:t>
           </a:r>
           <a:r>
             <a:rPr lang="en-GB" sz="1550" b="1" dirty="0" smtClean="0">
               <a:latin typeface="Calibri" panose="020F0502020204030204" pitchFamily="34" charset="0"/>
             </a:rPr>
-            <a:t>opportunities</a:t>
+            <a:t>DE: opportunities</a:t>
           </a:r>
           <a:endParaRPr lang="en-GB" sz="1550" b="1" dirty="0">
             <a:latin typeface="Calibri" panose="020F0502020204030204" pitchFamily="34" charset="0"/>

</xml_diff>

<commit_message>
[pptx-compose-mo19] Reconcile localized fixture provenance
</commit_message>
<xml_diff>
--- a/fixtures/real-world/oecd-economic-outlook-2017-de.pptx
+++ b/fixtures/real-world/oecd-economic-outlook-2017-de.pptx
@@ -2767,19 +2767,19 @@
             <a:rPr lang="en-GB" dirty="0" smtClean="0">
               <a:latin typeface="Calibri" panose="020F0502020204030204" pitchFamily="34" charset="0"/>
             </a:rPr>
-            <a:t>Globales Wachstum dürfte moderat anziehen </a:t>
+            <a:t>Global growth expected to pick-up modestly </a:t>
           </a:r>
           <a:r>
             <a:rPr lang="en-GB" smtClean="0">
               <a:latin typeface="Calibri" panose="020F0502020204030204" pitchFamily="34" charset="0"/>
             </a:rPr>
-            <a:t>mit Aufwärts</a:t>
+            <a:t>with upside </a:t>
           </a:r>
           <a:r>
             <a:rPr lang="en-GB" dirty="0" smtClean="0">
               <a:latin typeface="Calibri" panose="020F0502020204030204" pitchFamily="34" charset="0"/>
             </a:rPr>
-            <a:t>risiken</a:t>
+            <a:t>risks</a:t>
           </a:r>
         </a:p>
       </dgm:t>
@@ -2821,7 +2821,7 @@
             <a:rPr lang="en-GB" dirty="0" smtClean="0">
               <a:latin typeface="Calibri" panose="020F0502020204030204" pitchFamily="34" charset="0"/>
             </a:rPr>
-            <a:t>Es bleibt mehr zu tun, um die Gewinne aus Strukturtrends und Handel breiter zu teilen</a:t>
+            <a:t>More needs to be done to share the gains from structural trends and trade</a:t>
           </a:r>
         </a:p>
       </dgm:t>
@@ -2863,7 +2863,7 @@
             <a:rPr lang="en-GB" dirty="0" smtClean="0">
               <a:latin typeface="Calibri" panose="020F0502020204030204" pitchFamily="34" charset="0"/>
             </a:rPr>
-            <a:t>Ein integrierter Politikansatz ist nötig, damit die Globalisierung allen zugutekommt</a:t>
+            <a:t>An integrated policy approach is needed to make globalisation work for all</a:t>
           </a:r>
         </a:p>
       </dgm:t>
@@ -2910,7 +2910,7 @@
               </a:solidFill>
               <a:latin typeface="Calibri" panose="020F0502020204030204" pitchFamily="34" charset="0"/>
             </a:rPr>
-            <a:t>Veränderungen bei Technologie, Verbraucherpräferenzen und Handel vollziehen sich gleichzeitig</a:t>
+            <a:t>Changes to technology, consumer preferences and trade are occurring simultaneously</a:t>
           </a:r>
         </a:p>
       </dgm:t>
@@ -2958,7 +2958,7 @@
               </a:solidFill>
               <a:latin typeface="Calibri" panose="020F0502020204030204" pitchFamily="34" charset="0"/>
             </a:rPr>
-            <a:t>Gleichere Wettbewerbsbedingungen für das internationale System</a:t>
+            <a:t>A more level playing field for the international system</a:t>
           </a:r>
         </a:p>
       </dgm:t>
@@ -3005,7 +3005,7 @@
               </a:solidFill>
               <a:latin typeface="Calibri" panose="020F0502020204030204" pitchFamily="34" charset="0"/>
             </a:rPr>
-            <a:t>Das Vertrauen steigt, und Investitionen und Handel ziehen von niedrigem Niveau aus an</a:t>
+            <a:t>Confidence is increasing and investment and trade are picking up from low levels</a:t>
           </a:r>
         </a:p>
       </dgm:t>
@@ -3052,7 +3052,7 @@
               </a:solidFill>
               <a:latin typeface="Calibri" panose="020F0502020204030204" pitchFamily="34" charset="0"/>
             </a:rPr>
-            <a:t>Anzeichen für steigende Nachfrage nach Hightech-Gütern und Investitionen zur Modernisierung des Kapitals</a:t>
+            <a:t>Signs of rising demand for high-tech goods and investment to upgrade capital</a:t>
           </a:r>
         </a:p>
       </dgm:t>
@@ -3100,7 +3100,7 @@
               </a:solidFill>
               <a:latin typeface="Calibri" panose="020F0502020204030204" pitchFamily="34" charset="0"/>
             </a:rPr>
-            <a:t>Inländische Reformen zur Stärkung von Wettbewerb, Beschäftigung, Qualifikationen und Innovation</a:t>
+            <a:t>Domestic reforms to boost competition, job creation, skills and innovation</a:t>
           </a:r>
         </a:p>
       </dgm:t>
@@ -3142,7 +3142,7 @@
             <a:rPr lang="en-GB" dirty="0" smtClean="0">
               <a:latin typeface="Calibri" panose="020F0502020204030204" pitchFamily="34" charset="0"/>
             </a:rPr>
-            <a:t>Produktivitäts- und Lohnwachstum bleiben gedämpft; Risiken für die Finanzstabilität bestehen fort</a:t>
+            <a:t>Productivity and wage growth remain subdued; financial stability risks persist</a:t>
           </a:r>
         </a:p>
       </dgm:t>
@@ -3189,7 +3189,7 @@
               </a:solidFill>
               <a:latin typeface="Calibri" panose="020F0502020204030204" pitchFamily="34" charset="0"/>
             </a:rPr>
-            <a:t>Arbeitsplatzverluste durch Aktivitätsverlagerungen konzentrieren sich auf das verarbeitende Gewerbe und bestimmte Regionen</a:t>
+            <a:t>Job losses from shifts in activity are concentrated in manufacturing and specific regions</a:t>
           </a:r>
         </a:p>
       </dgm:t>
@@ -3236,7 +3236,7 @@
               </a:solidFill>
               <a:latin typeface="Calibri" panose="020F0502020204030204" pitchFamily="34" charset="0"/>
             </a:rPr>
-            <a:t>Das Wachstum ist breit angelegt; die Erholung bei Rohstoffproduzenten stützt den moderaten globalen Aufschwung</a:t>
+            <a:t>Growth is broad based; recovery in commodity producers helps the modest global upturn</a:t>
           </a:r>
           <a:endParaRPr lang="en-GB" dirty="0" smtClean="0">
             <a:solidFill>
@@ -3291,7 +3291,7 @@
               </a:solidFill>
               <a:latin typeface="Calibri" panose="020F0502020204030204" pitchFamily="34" charset="0"/>
             </a:rPr>
-            <a:t>Die wichtigsten Beschäftigungsindikatoren verbessern sich, doch die Arbeitsmärkte haben sich noch nicht erholt</a:t>
+            <a:t>Headline employment indicators are improving but labour markets have not recovered</a:t>
           </a:r>
         </a:p>
       </dgm:t>
@@ -3338,7 +3338,7 @@
               </a:solidFill>
               <a:latin typeface="Calibri" panose="020F0502020204030204" pitchFamily="34" charset="0"/>
             </a:rPr>
-            <a:t>Finanzielle Risiken durch hohes und steigendes Kreditwachstum, steigende Immobilienpreise und Zinsdivergenzen</a:t>
+            <a:t>Financial risks from high and rising credit growth, house price increases, interest rate gaps</a:t>
           </a:r>
           <a:endParaRPr lang="en-GB" dirty="0" smtClean="0">
             <a:solidFill>
@@ -3394,7 +3394,7 @@
               </a:solidFill>
               <a:latin typeface="Calibri" panose="020F0502020204030204" pitchFamily="34" charset="0"/>
             </a:rPr>
-            <a:t>Gezielte Maßnahmen, um Menschen, die zurückbleiben, neue Chancen zu eröffnen</a:t>
+            <a:t>Targeted policies to help people who are left behind seize new opportunities</a:t>
           </a:r>
         </a:p>
       </dgm:t>
@@ -3636,7 +3636,7 @@
             <a:rPr lang="en-GB" sz="2000" dirty="0" smtClean="0">
               <a:latin typeface="Calibri" panose="020F0502020204030204" pitchFamily="34" charset="0"/>
             </a:rPr>
-            <a:t>Maßnahmen zur Verbesserung des internationalen Umfelds:</a:t>
+            <a:t>Actions to improve the international environment:</a:t>
           </a:r>
         </a:p>
       </dgm:t>
@@ -3683,7 +3683,7 @@
               </a:solidFill>
               <a:latin typeface="Calibri" panose="020F0502020204030204" pitchFamily="34" charset="0"/>
             </a:rPr>
-            <a:t>Institutionen und Standards bewahren, etwa für Arbeits- und Umweltschutz</a:t>
+            <a:t>Preserve institutions and standards, such as for labour and environmental protection</a:t>
           </a:r>
         </a:p>
       </dgm:t>
@@ -3730,7 +3730,7 @@
               </a:solidFill>
               <a:latin typeface="Calibri" panose="020F0502020204030204" pitchFamily="34" charset="0"/>
             </a:rPr>
-            <a:t>Offene Märkte für grenzüberschreitenden Handel und Investitionen anstreben</a:t>
+            <a:t>Pursue open markets for cross-border trade and investment</a:t>
           </a:r>
         </a:p>
       </dgm:t>
@@ -3777,7 +3777,7 @@
               </a:solidFill>
               <a:latin typeface="Calibri" panose="020F0502020204030204" pitchFamily="34" charset="0"/>
             </a:rPr>
-            <a:t>Multilaterale Zusammenarbeit fördern, z. B. bei Gewinnverkürzung und Gewinnverlagerung sowie der Wettbewerbspolitik</a:t>
+            <a:t>Promote multilateral cooperation, e.g. on tax base erosion and profit shifting and competition policy</a:t>
           </a:r>
         </a:p>
       </dgm:t>
@@ -3824,7 +3824,7 @@
               </a:solidFill>
               <a:latin typeface="Calibri" panose="020F0502020204030204" pitchFamily="34" charset="0"/>
             </a:rPr>
-            <a:t>Korruption, illegalen Handel und Produktfälschung bekämpfen</a:t>
+            <a:t>Combat corruption, illicit trade and counterfeiting</a:t>
           </a:r>
         </a:p>
       </dgm:t>
@@ -4079,7 +4079,7 @@
             <a:rPr lang="en-GB" sz="1600" b="1" dirty="0" smtClean="0">
               <a:latin typeface="Calibri" panose="020F0502020204030204" pitchFamily="34" charset="0"/>
             </a:rPr>
-            <a:t>Das internationale System gerechter gestalten und besser zum Funktionieren bringen</a:t>
+            <a:t>Make the international system fairer and work better</a:t>
           </a:r>
           <a:endParaRPr lang="en-GB" sz="1600" b="1" dirty="0">
             <a:latin typeface="Calibri" panose="020F0502020204030204" pitchFamily="34" charset="0"/>
@@ -4127,7 +4127,7 @@
               </a:solidFill>
               <a:latin typeface="Calibri" panose="020F0502020204030204" pitchFamily="34" charset="0"/>
             </a:rPr>
-            <a:t>Maßnahmen zur Förderung neuer Unternehmen, Innovation und Beschäftigung</a:t>
+            <a:t>Policies to encourage new firms, innovation &amp; job creation</a:t>
           </a:r>
           <a:endParaRPr lang="en-GB" sz="1600" b="1" dirty="0">
             <a:solidFill>
@@ -4175,13 +4175,13 @@
             <a:rPr lang="en-GB" sz="1600" b="1" dirty="0" smtClean="0">
               <a:latin typeface="Calibri" panose="020F0502020204030204" pitchFamily="34" charset="0"/>
             </a:rPr>
-            <a:t>Gezielte Maßnahmen, um Menschen zu helfen, neue </a:t>
+            <a:t>Targeted policies to help people seize new </a:t>
           </a:r>
           <a:r>
             <a:rPr lang="en-GB" sz="1550" b="1" dirty="0" smtClean="0">
               <a:latin typeface="Calibri" panose="020F0502020204030204" pitchFamily="34" charset="0"/>
             </a:rPr>
-            <a:t>Chancen zu ergreifen</a:t>
+            <a:t>opportunities</a:t>
           </a:r>
           <a:endParaRPr lang="en-GB" sz="1550" b="1" dirty="0">
             <a:latin typeface="Calibri" panose="020F0502020204030204" pitchFamily="34" charset="0"/>
@@ -4433,19 +4433,19 @@
             <a:rPr lang="en-GB" sz="2000" kern="1200" dirty="0" smtClean="0">
               <a:latin typeface="Calibri" panose="020F0502020204030204" pitchFamily="34" charset="0"/>
             </a:rPr>
-            <a:t>Globales Wachstum dürfte moderat anziehen </a:t>
+            <a:t>Global growth expected to pick-up modestly </a:t>
           </a:r>
           <a:r>
             <a:rPr lang="en-GB" sz="2000" kern="1200" smtClean="0">
               <a:latin typeface="Calibri" panose="020F0502020204030204" pitchFamily="34" charset="0"/>
             </a:rPr>
-            <a:t>mit Aufwärts</a:t>
+            <a:t>with upside </a:t>
           </a:r>
           <a:r>
             <a:rPr lang="en-GB" sz="2000" kern="1200" dirty="0" smtClean="0">
               <a:latin typeface="Calibri" panose="020F0502020204030204" pitchFamily="34" charset="0"/>
             </a:rPr>
-            <a:t>risiken</a:t>
+            <a:t>risks</a:t>
           </a:r>
         </a:p>
       </dsp:txBody>
@@ -4512,7 +4512,7 @@
               </a:solidFill>
               <a:latin typeface="Calibri" panose="020F0502020204030204" pitchFamily="34" charset="0"/>
             </a:rPr>
-            <a:t>Es bleibt mehr zu tun, um die Gewinne aus Strukturtrends und Handel breiter zu teilen</a:t>
+            <a:t>Confidence is increasing and investment and trade are picking up from low levels</a:t>
           </a:r>
         </a:p>
         <a:p>
@@ -4537,7 +4537,7 @@
               </a:solidFill>
               <a:latin typeface="Calibri" panose="020F0502020204030204" pitchFamily="34" charset="0"/>
             </a:rPr>
-            <a:t>Ein integrierter Politikansatz ist nötig, damit die Globalisierung allen zugutekommt</a:t>
+            <a:t>Growth is broad based; recovery in commodity producers helps the modest global upturn</a:t>
           </a:r>
           <a:endParaRPr lang="en-GB" sz="1600" kern="1200" dirty="0" smtClean="0">
             <a:solidFill>
@@ -4570,7 +4570,7 @@
               </a:solidFill>
               <a:latin typeface="Calibri" panose="020F0502020204030204" pitchFamily="34" charset="0"/>
             </a:rPr>
-            <a:t>Veränderungen bei Technologie, Verbraucherpräferenzen und Handel vollziehen sich gleichzeitig</a:t>
+            <a:t>Signs of rising demand for high-tech goods and investment to upgrade capital</a:t>
           </a:r>
         </a:p>
       </dsp:txBody>
@@ -4648,7 +4648,7 @@
             <a:rPr lang="en-GB" sz="2000" kern="1200" dirty="0" smtClean="0">
               <a:latin typeface="Calibri" panose="020F0502020204030204" pitchFamily="34" charset="0"/>
             </a:rPr>
-            <a:t>Gleichere Wettbewerbsbedingungen für das internationale System</a:t>
+            <a:t>Productivity and wage growth remain subdued; financial stability risks persist</a:t>
           </a:r>
         </a:p>
       </dsp:txBody>
@@ -4715,7 +4715,7 @@
               </a:solidFill>
               <a:latin typeface="Calibri" panose="020F0502020204030204" pitchFamily="34" charset="0"/>
             </a:rPr>
-            <a:t>Das Vertrauen steigt, und Investitionen und Handel ziehen von niedrigem Niveau aus an</a:t>
+            <a:t>Headline employment indicators are improving but labour markets have not recovered</a:t>
           </a:r>
         </a:p>
         <a:p>
@@ -4740,7 +4740,7 @@
               </a:solidFill>
               <a:latin typeface="Calibri" panose="020F0502020204030204" pitchFamily="34" charset="0"/>
             </a:rPr>
-            <a:t>Anzeichen für steigende Nachfrage nach Hightech-Gütern und Investitionen zur Modernisierung des Kapitals</a:t>
+            <a:t>Financial risks from high and rising credit growth, house price increases, interest rate gaps</a:t>
           </a:r>
           <a:endParaRPr lang="en-GB" sz="1600" kern="1200" dirty="0" smtClean="0">
             <a:solidFill>
@@ -4826,7 +4826,7 @@
             <a:rPr lang="en-GB" sz="2000" kern="1200" dirty="0" smtClean="0">
               <a:latin typeface="Calibri" panose="020F0502020204030204" pitchFamily="34" charset="0"/>
             </a:rPr>
-            <a:t>Inländische Reformen zur Stärkung von Wettbewerb, Beschäftigung, Qualifikationen und Innovation</a:t>
+            <a:t>More needs to be done to share the gains from structural trends and trade</a:t>
           </a:r>
         </a:p>
       </dsp:txBody>
@@ -4893,7 +4893,7 @@
               </a:solidFill>
               <a:latin typeface="Calibri" panose="020F0502020204030204" pitchFamily="34" charset="0"/>
             </a:rPr>
-            <a:t>Produktivitäts- und Lohnwachstum bleiben gedämpft; Risiken für die Finanzstabilität bestehen fort</a:t>
+            <a:t>Changes to technology, consumer preferences and trade are occurring simultaneously</a:t>
           </a:r>
         </a:p>
         <a:p>
@@ -4918,7 +4918,7 @@
               </a:solidFill>
               <a:latin typeface="Calibri" panose="020F0502020204030204" pitchFamily="34" charset="0"/>
             </a:rPr>
-            <a:t>Arbeitsplatzverluste durch Aktivitätsverlagerungen konzentrieren sich auf das verarbeitende Gewerbe und bestimmte Regionen</a:t>
+            <a:t>Job losses from shifts in activity are concentrated in manufacturing and specific regions</a:t>
           </a:r>
         </a:p>
       </dsp:txBody>
@@ -4996,7 +4996,7 @@
             <a:rPr lang="en-GB" sz="2000" kern="1200" dirty="0" smtClean="0">
               <a:latin typeface="Calibri" panose="020F0502020204030204" pitchFamily="34" charset="0"/>
             </a:rPr>
-            <a:t>Das Wachstum ist breit angelegt; die Erholung bei Rohstoffproduzenten stützt den moderaten globalen Aufschwung</a:t>
+            <a:t>An integrated policy approach is needed to make globalisation work for all</a:t>
           </a:r>
         </a:p>
       </dsp:txBody>
@@ -5063,7 +5063,7 @@
               </a:solidFill>
               <a:latin typeface="Calibri" panose="020F0502020204030204" pitchFamily="34" charset="0"/>
             </a:rPr>
-            <a:t>Die wichtigsten Beschäftigungsindikatoren verbessern sich, doch die Arbeitsmärkte haben sich noch nicht erholt</a:t>
+            <a:t>A more level playing field for the international system</a:t>
           </a:r>
         </a:p>
         <a:p>
@@ -5088,7 +5088,7 @@
               </a:solidFill>
               <a:latin typeface="Calibri" panose="020F0502020204030204" pitchFamily="34" charset="0"/>
             </a:rPr>
-            <a:t>Finanzielle Risiken durch hohes und steigendes Kreditwachstum, steigende Immobilienpreise und Zinsdivergenzen</a:t>
+            <a:t>Domestic reforms to boost competition, job creation, skills and innovation</a:t>
           </a:r>
         </a:p>
         <a:p>
@@ -5113,7 +5113,7 @@
               </a:solidFill>
               <a:latin typeface="Calibri" panose="020F0502020204030204" pitchFamily="34" charset="0"/>
             </a:rPr>
-            <a:t>Gezielte Maßnahmen, um Menschen, die zurückbleiben, neue Chancen zu eröffnen</a:t>
+            <a:t>Targeted policies to help people who are left behind seize new opportunities</a:t>
           </a:r>
         </a:p>
       </dsp:txBody>

</xml_diff>